<commit_message>
Simpler app: one search page in the query -> ranked-matches style of Re-ID demos
- Search page: 1 find the vehicle (describe it, or pick it from a camera),
  2 its route across cameras, 3 where else was it seen (top-3 ranked matches per
  camera with one-click confirmation, re-ranked against every confirmed view)
- Analysis page: VeRi-776 results, SOM vehicle map, tracking check
- Demo cameras load automatically; uploads, matching settings and sign-out in the sidebar
- Uniform 4:3 thumbnails; evidence table behind "Why these matches?"
- Tests, screenshots, demo guide, report, README and deck updated

Co-Authored-By: Claude Opus 5.5 <noreply@anthropic.com>
</commit_message>
<xml_diff>
--- a/deliverables/V-Trace_Final_Presentation.pptx
+++ b/deliverables/V-Trace_Final_Presentation.pptx
@@ -2195,7 +2195,7 @@
           <a:lstStyle/>
           <a:p>
             <a:r>
-              <a:t>Now the app. After the admin signs in, the quick demo loads the four cameras. I describe the target as a red sedan; the red Citroën in camera A is ranked first and I confirm it. In step three the route view already suggests camera B; I confirm it, camera C is re-scored against both views, and I confirm the sighting there — giving the full route from camera A to B to C in time order, with the evidence for every step.</a:t>
+              <a:t>Now the app. It has one search page. After the admin signs in, the four demo cameras are already loaded. Step one: I describe the target as a red sedan; the red Citroën in camera A is ranked first and I select it. Step three shows the best three matches in every other camera, like a re-identification result list; the starred match in camera B is the same car, so I confirm it, camera C is re-ranked against both views, and I confirm the sighting there. Step two now shows the full route from camera A to B to C in time order.</a:t>
             </a:r>
           </a:p>
         </p:txBody>
@@ -2475,7 +2475,7 @@
           <a:lstStyle/>
           <a:p>
             <a:r>
-              <a:t>This is the workflow, as in the proposal, now with a sixth step. Upload the camera videos, or use the one-click demo. Describe the vehicle with whatever is known. Stage one ranks every tracked vehicle. The user confirms the right candidate, which becomes the visual query. Stage two re-identifies it in the other cameras. And the new trace step suggests the route and lets the user confirm the sighting in each camera with one click.</a:t>
+              <a:t>This is the workflow, as in the proposal, now with a sixth step. Upload the camera videos; the demo cameras are preloaded. Describe the vehicle with whatever is known. Stage one ranks every tracked vehicle. The user confirms the right candidate, which becomes the visual query. Stage two re-identifies it in the other cameras. And the new trace step suggests the route and lets the user confirm the sighting in each camera with one click.</a:t>
             </a:r>
           </a:p>
         </p:txBody>
@@ -10431,7 +10431,7 @@
                 </a:solidFill>
                 <a:latin typeface="Aptos"/>
               </a:rPr>
-              <a:t>Describe → search → confirm → re-identify → trace, in the Streamlit app.</a:t>
+              <a:t>One page: find the vehicle → see where else it was seen → follow its route.</a:t>
             </a:r>
           </a:p>
         </p:txBody>
@@ -10640,7 +10640,7 @@
                 </a:solidFill>
                 <a:latin typeface="Aptos Display"/>
               </a:rPr>
-              <a:t>Stage 1 · “red + sedan” → ranked candidates → confirm</a:t>
+              <a:t>① Find: “red + sedan” → ranked vehicles → Select</a:t>
             </a:r>
           </a:p>
         </p:txBody>
@@ -10751,7 +10751,7 @@
                 </a:solidFill>
                 <a:latin typeface="Aptos Display"/>
               </a:rPr>
-              <a:t>Stage 2 · route confirmed camA → camB → camC</a:t>
+              <a:t>② Route confirmed camA → camB → camC</a:t>
             </a:r>
           </a:p>
         </p:txBody>
@@ -13302,7 +13302,7 @@
                 </a:solidFill>
                 <a:latin typeface="Aptos"/>
               </a:rPr>
-              <a:t>(or Quick demo)</a:t>
+              <a:t>(demo cameras preloaded)</a:t>
             </a:r>
           </a:p>
         </p:txBody>
@@ -15904,7 +15904,7 @@
                 </a:solidFill>
                 <a:latin typeface="Aptos"/>
               </a:rPr>
-              <a:t>Streamlit app: sign-in · upload · search · re-identify · route · track review · SOM · evaluation</a:t>
+              <a:t>Streamlit app: Search page (find → route → where else) · Analysis page (benchmark · SOM · tracking check)</a:t>
             </a:r>
           </a:p>
         </p:txBody>

</xml_diff>

<commit_message>
Real-world camera details: location + recording start for every camera
- vtrace/cameras.py: a sighting's real-world time = camera recording start + position in the video;
  curated details for the demo cameras (camA-C one street/same clock, camD another road 2.5 min later)
- Uploads ask for location, recording date/time (+ optional lat/lon); new Cameras page edits them
- Results show location, real-world date/time, video position, time between cameras and a map
- Re-ID time window now uses real-world time (5 s - 12 h); unknown starts are not time-limited
- Tests, demo evaluation, docs, deck and reports updated

Co-Authored-By: Claude Opus 5.5 <noreply@anthropic.com>
</commit_message>
<xml_diff>
--- a/deliverables/V-Trace_Final_Presentation.pptx
+++ b/deliverables/V-Trace_Final_Presentation.pptx
@@ -823,7 +823,7 @@
           <a:lstStyle/>
           <a:p>
             <a:r>
-              <a:t>On real street video the same model is much weaker: vehicles are small and seen from very different angles. The correct sighting is ranked first for 36 percent of queries. That is why the decision rule matters. With the ratio test and the ten-second window, 71 percent of the cameras V-Trace reports are correct, and only 7 percent of queries are wrongly placed on the other road. It finds 32 percent of the cameras – for the rest it shows the closest vehicles so the user can decide.</a:t>
+              <a:t>On real street video the same model is much weaker: vehicles are small and seen from very different angles. The correct sighting is ranked first for 36 percent of queries. That is why the decision rule matters. With the ratio test and a ten-second real-world time window, 81 percent of the cameras V-Trace reports are correct. Part of that comes from the curated clocks: the other road was recorded minutes later, so the window rules it out. Without the window, the model and ratio test alone reach 53 percent, with 16 percent of queries wrongly placed on the other road. It finds 32 percent of the cameras – for the rest it shows the closest vehicles so the user can decide.</a:t>
             </a:r>
           </a:p>
         </p:txBody>
@@ -893,7 +893,7 @@
           <a:lstStyle/>
           <a:p>
             <a:r>
-              <a:t>Now the app. After the admin signs in, the four demo cameras are already processed. I describe the target: colour red, type SUV, and search. The ranked matches show red cars; number three is a red Citroën in camera B at 42 seconds. I select it, and V-Trace shows where it was seen: camera A at 40.8 seconds, camera B at 42.0 and camera C at 43.6, each with its time span, a crop and the full frame. The other road is listed as not seen.</a:t>
+              <a:t>Now the app. After the admin signs in, the four demo cameras are already processed. I describe the target: colour red, type SUV, and search. The ranked matches show red cars; number three is a red Citroën in camera B at 42 seconds past 8:15. I select it, and V-Trace shows where it was seen: Slovenska cesta west at 8:15:40.8, at the crossing at 8:15:42.0 and east at 8:15:43.5, each with location, date and time, a crop and the full frame, plus a map. The other road, recorded minutes later, is listed as not seen. On the Cameras page each camera's location and recording start can be edited, and the route updates.</a:t>
             </a:r>
           </a:p>
         </p:txBody>
@@ -963,7 +963,7 @@
           <a:lstStyle/>
           <a:p>
             <a:r>
-              <a:t>Three lessons. First, a published model trained by the dataset's own authors beat anything I could train in ten days, but I verified it by re-running the official benchmark before trusting it. Second, benchmark accuracy does not transfer: on my street footage rank-one dropped to about 36 percent. Third, decision rules matter as much as scores: a ratio test and a time window raised the share of correct cameras from about 40 to 71 percent without any training.</a:t>
+              <a:t>Three lessons. First, a published model trained by the dataset's own authors beat anything I could train in ten days, but I verified it by re-running the official benchmark before trusting it. Second, benchmark accuracy does not transfer: on my street footage rank-one dropped to about 36 percent. Third, decision rules matter as much as scores: a ratio test and a time window raised the share of correct cameras from about 40 to 81 percent without any training.</a:t>
             </a:r>
           </a:p>
         </p:txBody>
@@ -1103,7 +1103,7 @@
           <a:lstStyle/>
           <a:p>
             <a:r>
-              <a:t>To conclude: V-Trace turns camera videos into searchable sightings, ranks them against a description, and once the user selects the right vehicle, shows every camera it was seen in with times and frames. It is built entirely from published pretrained models; the Re-ID model reproduces its benchmark accuracy, and on real street footage the cameras it reports are correct 71 percent of the time. Thank you – I'm happy to take questions.</a:t>
+              <a:t>To conclude: V-Trace turns camera videos into searchable sightings, ranks them against a description, and once the user selects the right vehicle, shows every camera it was seen in with times and frames. It is built entirely from published pretrained models; the Re-ID model reproduces its benchmark accuracy, and on real street footage the cameras it reports are correct 81 percent of the time. Thank you – I'm happy to take questions.</a:t>
             </a:r>
           </a:p>
         </p:txBody>
@@ -1243,7 +1243,7 @@
           <a:lstStyle/>
           <a:p>
             <a:r>
-              <a:t>This is the workflow. First, choose the videos: the demo cameras already on the platform, or upload short dash-cam or traffic-cam clips. Each video is processed: every vehicle is detected and followed while it stays in view – for example a red sedan visible for four seconds in camera one is one sighting. The user describes the vehicle, V-Trace ranks the best matches, the user selects one, and V-Trace shows every camera where the same vehicle was seen, with the time span and a frame.</a:t>
+              <a:t>This is the workflow. First, choose the videos: the demo cameras already on the platform, or upload short dash-cam or traffic-cam clips. Each video is processed: every vehicle is detected and followed while it stays in view – for example a red sedan visible for four seconds in camera one is one sighting. The user describes the vehicle, V-Trace ranks the best matches, the user selects one, and V-Trace shows every camera where the same vehicle was seen, with the camera's location, the real-world date and time, and a frame. Real-world time is the camera's recording start plus the position in the video, so cameras can be seconds, minutes or hours apart.</a:t>
             </a:r>
           </a:p>
         </p:txBody>
@@ -1453,7 +1453,7 @@
           <a:lstStyle/>
           <a:p>
             <a:r>
-              <a:t>Two scoring steps. For the description, every field the user fills in gives each sighting a score between zero and one, and the final score is the weighted mean over only those fields, so leaving a field empty never hurts. For re-identification, the similarity of two sightings is the cosine of their FastReID signatures. A camera counts as 'seen' only if its best sighting is above 0.40, beats the camera's second-best by 0.08 – a ratio test, so look-alike cars are left to the user – and, for cameras that share a clock, is within ten seconds.</a:t>
+              <a:t>Two scoring steps. For the description, every field the user fills in gives each sighting a score between zero and one, and the final score is the weighted mean over only those fields, so leaving a field empty never hurts. For re-identification, the similarity of two sightings is the cosine of their FastReID signatures. A camera counts as 'seen' only if its best sighting is above 0.40, beats the camera's second-best by 0.08 – a ratio test, so look-alike cars are left to the user – and is within ten seconds in real-world time, which is each camera's recording start plus the position in its video.</a:t>
             </a:r>
           </a:p>
         </p:txBody>
@@ -5307,7 +5307,7 @@
                 </a:solidFill>
                 <a:latin typeface="Aptos Display"/>
               </a:rPr>
-              <a:t>71%</a:t>
+              <a:t>81%</a:t>
             </a:r>
           </a:p>
         </p:txBody>
@@ -5346,7 +5346,7 @@
                 </a:solidFill>
                 <a:latin typeface="Aptos"/>
               </a:rPr>
-              <a:t>reported cameras correct (no time window: 53%)</a:t>
+              <a:t>reported cameras correct, 10 s real-time window (none: 53%)</a:t>
             </a:r>
           </a:p>
         </p:txBody>
@@ -5559,7 +5559,7 @@
                 </a:solidFill>
                 <a:latin typeface="Aptos Display"/>
               </a:rPr>
-              <a:t>7%</a:t>
+              <a:t>0% / 16%</a:t>
             </a:r>
           </a:p>
         </p:txBody>
@@ -5598,7 +5598,7 @@
                 </a:solidFill>
                 <a:latin typeface="Aptos"/>
               </a:rPr>
-              <a:t>queries wrongly placed on the other road</a:t>
+              <a:t>placed on the other road, with / without window</a:t>
             </a:r>
           </a:p>
         </p:txBody>
@@ -6046,7 +6046,7 @@
                 </a:solidFill>
                 <a:latin typeface="Aptos Display"/>
               </a:rPr>
-              <a:t>Route camA → camB → camC with time spans and frames</a:t>
+              <a:t>Route with location, real-world time and a frame per camera</a:t>
             </a:r>
           </a:p>
         </p:txBody>
@@ -7058,7 +7058,7 @@
                 </a:solidFill>
                 <a:latin typeface="Aptos Display"/>
               </a:rPr>
-              <a:t>Precision ~40% → 71%</a:t>
+              <a:t>Precision ~40% → 81%</a:t>
             </a:r>
           </a:p>
         </p:txBody>
@@ -8158,7 +8158,7 @@
                 </a:solidFill>
                 <a:latin typeface="Aptos Display"/>
               </a:rPr>
-              <a:t>71%</a:t>
+              <a:t>81%</a:t>
             </a:r>
           </a:p>
         </p:txBody>
@@ -9050,7 +9050,7 @@
                 </a:solidFill>
                 <a:latin typeface="Aptos Display"/>
               </a:rPr>
-              <a:t>Find a vehicle from a description, then show every camera it was seen in – with time span and a frame from each sighting.</a:t>
+              <a:t>Find a vehicle from a description, then show every camera it was seen in – with location, real-world time and a frame from each sighting.</a:t>
             </a:r>
           </a:p>
         </p:txBody>
@@ -10007,7 +10007,7 @@
                 </a:solidFill>
                 <a:latin typeface="Aptos"/>
               </a:rPr>
-              <a:t>#1 camA · 0:41</a:t>
+              <a:t>#1 camA · 08:15:29</a:t>
             </a:r>
           </a:p>
           <a:p>
@@ -10023,7 +10023,7 @@
                 </a:solidFill>
                 <a:latin typeface="Aptos"/>
               </a:rPr>
-              <a:t>#2 camB · 0:42</a:t>
+              <a:t>#2 camA · 08:15:40</a:t>
             </a:r>
           </a:p>
           <a:p>
@@ -10039,7 +10039,7 @@
                 </a:solidFill>
                 <a:latin typeface="Aptos"/>
               </a:rPr>
-              <a:t>#3 camC · 0:03</a:t>
+              <a:t>#3 camB · 08:15:42</a:t>
             </a:r>
           </a:p>
         </p:txBody>
@@ -10379,7 +10379,39 @@
                 </a:solidFill>
                 <a:latin typeface="Aptos"/>
               </a:rPr>
-              <a:t>camA 0:41 → camB 0:42 → camC 0:44</a:t>
+              <a:t>Location + real time</a:t>
+            </a:r>
+          </a:p>
+          <a:p>
+            <a:pPr algn="l">
+              <a:spcAft>
+                <a:spcPts val="200"/>
+              </a:spcAft>
+            </a:pPr>
+            <a:r>
+              <a:rPr sz="1400" b="0" i="0">
+                <a:solidFill>
+                  <a:srgbClr val="2B333C"/>
+                </a:solidFill>
+                <a:latin typeface="Aptos"/>
+              </a:rPr>
+              <a:t>camA 08:15:40</a:t>
+            </a:r>
+          </a:p>
+          <a:p>
+            <a:pPr algn="l">
+              <a:spcAft>
+                <a:spcPts val="200"/>
+              </a:spcAft>
+            </a:pPr>
+            <a:r>
+              <a:rPr sz="1400" b="0" i="0">
+                <a:solidFill>
+                  <a:srgbClr val="2B333C"/>
+                </a:solidFill>
+                <a:latin typeface="Aptos"/>
+              </a:rPr>
+              <a:t>→ camB 08:15:42</a:t>
             </a:r>
           </a:p>
           <a:p>
@@ -12080,7 +12112,7 @@
                 </a:solidFill>
                 <a:latin typeface="Aptos"/>
               </a:rPr>
-              <a:t>Camera · time span</a:t>
+              <a:t>Location · real-world</a:t>
             </a:r>
           </a:p>
           <a:p>
@@ -12096,7 +12128,23 @@
                 </a:solidFill>
                 <a:latin typeface="Aptos"/>
               </a:rPr>
-              <a:t>· frame per sighting</a:t>
+              <a:t>time · frame per</a:t>
+            </a:r>
+          </a:p>
+          <a:p>
+            <a:pPr algn="l">
+              <a:spcAft>
+                <a:spcPts val="300"/>
+              </a:spcAft>
+            </a:pPr>
+            <a:r>
+              <a:rPr sz="1300" b="0" i="0">
+                <a:solidFill>
+                  <a:srgbClr val="2B333C"/>
+                </a:solidFill>
+                <a:latin typeface="Aptos"/>
+              </a:rPr>
+              <a:t>sighting · map</a:t>
             </a:r>
           </a:p>
         </p:txBody>
@@ -12135,7 +12183,7 @@
                 </a:solidFill>
                 <a:latin typeface="Aptos"/>
               </a:rPr>
-              <a:t>Sighting = all frames in which one vehicle is seen continuously in one camera</a:t>
+              <a:t>Sighting = one vehicle seen continuously in one camera · real-world time = camera recording start + position in video</a:t>
             </a:r>
           </a:p>
         </p:txBody>
@@ -12174,7 +12222,7 @@
                 </a:solidFill>
                 <a:latin typeface="Aptos"/>
               </a:rPr>
-              <a:t>Streamlit app with admin sign-in: Search page (describe → best matches → where seen) · How it works page</a:t>
+              <a:t>Streamlit app with admin sign-in: Search (describe → best matches → where seen) · Cameras (location + recording start) · How it works</a:t>
             </a:r>
           </a:p>
         </p:txBody>
@@ -14313,7 +14361,7 @@
                 </a:solidFill>
                 <a:latin typeface="Aptos"/>
               </a:rPr>
-              <a:t>•  Time window: </a:t>
+              <a:t>•  Real-world time: </a:t>
             </a:r>
             <a:r>
               <a:rPr sz="1500" b="0" i="0">
@@ -14322,7 +14370,7 @@
                 </a:solidFill>
                 <a:latin typeface="Aptos"/>
               </a:rPr>
-              <a:t>≤ 10 s when the cameras share a clock</a:t>
+              <a:t>camera recording start + position in the video; limit ≤ 10 s (5 s – 12 h)</a:t>
             </a:r>
           </a:p>
           <a:p>
@@ -14393,7 +14441,7 @@
                 </a:solidFill>
                 <a:latin typeface="Aptos Display"/>
               </a:rPr>
-              <a:t>EVERY RESULT COMES WITH ITS EVIDENCE: TIME SPAN · CROP · FRAME · SCORE</a:t>
+              <a:t>EVERY RESULT COMES WITH ITS EVIDENCE: LOCATION · REAL-WORLD TIME · CROP · FRAME · SCORE</a:t>
             </a:r>
           </a:p>
         </p:txBody>

</xml_diff>

<commit_message>
Singapore camera locations, upload test pack, simpler sidebar, IRS-format reports
- Curated demo/test camera locations moved to Singapore (Orchard Road / Bukit Timah Road)
- test_videos/: 7 upload-ready clips with built-in camera details and verified expected results
  (scripts/make_test_videos.py); details fill in automatically on upload
- Sidebar trimmed to video source, camera count, Settings and Sign out; upload form asks location + start time
- Demo evaluation adds a decision-rule ablation (threshold only / + ratio test / + real-time window)
- Final report restructured to the IRS report format; individual report in the PRS template (make_individual.py)
- Deck, demo guide, README and docs updated

Co-Authored-By: Claude Opus 5.5 <noreply@anthropic.com>
</commit_message>
<xml_diff>
--- a/deliverables/V-Trace_Final_Presentation.pptx
+++ b/deliverables/V-Trace_Final_Presentation.pptx
@@ -893,7 +893,7 @@
           <a:lstStyle/>
           <a:p>
             <a:r>
-              <a:t>Now the app. After the admin signs in, the four demo cameras are already processed. I describe the target: colour red, type SUV, and search. The ranked matches show red cars; number three is a red Citroën in camera B at 42 seconds past 8:15. I select it, and V-Trace shows where it was seen: Slovenska cesta west at 8:15:40.8, at the crossing at 8:15:42.0 and east at 8:15:43.5, each with location, date and time, a crop and the full frame, plus a map. The other road, recorded minutes later, is listed as not seen. On the Cameras page each camera's location and recording start can be edited, and the route updates.</a:t>
+              <a:t>Now the app. After the admin signs in, the four demo cameras are already processed. I describe the target: colour red, type SUV, and search. The ranked matches show red cars; number three is a red Citroën in camera B at 42 seconds past 8:15. I select it, and V-Trace shows where it was seen: Orchard Road west of Scotts Road at 8:15:40.8, at the Scotts Road junction at 8:15:42.0 and east of it at 8:15:43.5, each with location, date and time, a crop and the full frame, plus a map. The other road, recorded minutes later, is listed as not seen. On the Cameras page each camera's location and recording start can be edited, and the route updates.</a:t>
             </a:r>
           </a:p>
         </p:txBody>
@@ -963,7 +963,7 @@
           <a:lstStyle/>
           <a:p>
             <a:r>
-              <a:t>Three lessons. First, a published model trained by the dataset's own authors beat anything I could train in ten days, but I verified it by re-running the official benchmark before trusting it. Second, benchmark accuracy does not transfer: on my street footage rank-one dropped to about 36 percent. Third, decision rules matter as much as scores: a ratio test and a time window raised the share of correct cameras from about 40 to 81 percent without any training.</a:t>
+              <a:t>Three lessons. First, a published model trained by the dataset's own authors beat anything I could train in ten days, but I verified it by re-running the official benchmark before trusting it. Second, benchmark accuracy does not transfer: on my street footage rank-one dropped to about 36 percent. Third, decision rules matter as much as scores: a ratio test and a time window raised the share of correct cameras from 26 to 81 percent without any training.</a:t>
             </a:r>
           </a:p>
         </p:txBody>
@@ -7058,7 +7058,7 @@
                 </a:solidFill>
                 <a:latin typeface="Aptos Display"/>
               </a:rPr>
-              <a:t>Precision ~40% → 81%</a:t>
+              <a:t>Precision 26% → 81%</a:t>
             </a:r>
           </a:p>
         </p:txBody>

</xml_diff>